<commit_message>
Demo data and slides: Export Control & Customs example
- New persons Karsten Eschamann, Andreas Obermaier, Torsten Blaschke;
  managing director renamed to Konrad Garhammer
- New positions ST-014 Director Export Control & Customs, ST-015 Head
  of Legal & Compliance, ST-016 Leitung Controlling
- New role RO-015 Trade Compliance Beauftragter; RO-002 owned by
  Controlling
- New mandate DV-014 (appointment by the managing director / export
  control officer)
- Slides rebuilt with the new example

Co-Authored-By: Claude Opus 5.5 <noreply@anthropic.com>
Claude-Session: https://claude.ai/code/session_01VM9zZPfossgemHou7TrSjJ
</commit_message>
<xml_diff>
--- a/docs/folien-organisationsmodell.pptx
+++ b/docs/folien-organisationsmodell.pptx
@@ -110,12 +110,12 @@
   <p:extLst>
     <p:ext uri="{521415D9-36F7-43E2-AB2F-B90AF26B5E84}">
       <p14:sectionLst xmlns:p14="http://schemas.microsoft.com/office/powerpoint/2010/main">
-        <p14:section name="Big Picture" id="{bd306eb7-ffce-d9dc-00a8-bba1fc597279}">
+        <p14:section name="Big Picture" id="{5269d934-5cc5-c06e-5ad9-4a9494e950e6}">
           <p14:sldIdLst>
             <p14:sldId id="256"/>
           </p14:sldIdLst>
         </p14:section>
-        <p14:section name="Masken" id="{71d27aaa-d8aa-b061-a4ba-c4c4b08b57a3}">
+        <p14:section name="Masken" id="{4bcff528-f4f8-ac65-1da3-5daedb68c6ac}">
           <p14:sldIdLst>
             <p14:sldId id="257"/>
             <p14:sldId id="258"/>
@@ -614,7 +614,7 @@
           <a:p>
             <a:r>
               <a:rPr lang="en-US" dirty="0"/>
-              <a:t>Stammdaten, Stellenbeschreibung und Befugnisse der Stelle (links); Hierarchie, Stelleninhaber, Rollen mit Kommentar und abgeleitete Informationen inklusive der funktionalen Befugnisse aus den Rollen (Mitte); Anforderungen, Normbezug und Review (rechts).</a:t>
+              <a:t>Die Stelle beschreibt Zweck, Aufgaben und Befugnisse der Position: Führung des Teams, Budget der Kostenstelle 4710 bis 50.000 EUR, Freigabe von Exportvorgängen. Disziplinarisch berichtet sie an Andreas Obermaier (Head of Legal &amp; Compliance), fachlich an die Geschäftsführung als Ausfuhrverantwortlichen. Die Stelle bündelt die Rollen Trade Compliance Beauftragter und Kostenstellenverantwortlicher; die Beauftragung DV-014 ist bei den Stelleninhabern als wirksam sichtbar.</a:t>
             </a:r>
             <a:endParaRPr lang="en-US" dirty="0"/>
           </a:p>
@@ -702,7 +702,7 @@
           <a:p>
             <a:r>
               <a:rPr lang="en-US" dirty="0"/>
-              <a:t>Die Rolle beschreibt Pflichten und funktionale Befugnisse für jeden Inhaber. Die Inhaber ergeben sich aus den Stellen. Im Abschnitt Erforderliche Übertragung steht je Inhaber der Stand der Bestellung; eine fehlende Bestellung lässt sich direkt anlegen. Zusätzlich zeigt der Handlungsbedarf die Funktionstrennung (ISB und IT-Administration bei Daniel Becker).</a:t>
+              <a:t>Die Rolle beschreibt abstrakt, was ein Kostenstellenverantwortlicher tut und darf – unabhängig davon, welche Kostenstelle und welcher Betrag. Die konkreten Limits stehen im Kommentar an der jeweiligen Stelle bzw. als Freigabelimit der Stelle. Rollenverantwortlicher ist Torsten Blaschke (Leitung Controlling). Die Rolle ist mit Einkäufer unvereinbar (Funktionstrennung).</a:t>
             </a:r>
             <a:endParaRPr lang="en-US" dirty="0"/>
           </a:p>
@@ -790,7 +790,7 @@
           <a:p>
             <a:r>
               <a:rPr lang="en-US" dirty="0"/>
-              <a:t>Pflichtendelegation nach § 13 Abs. 2 ArbSchG an Petra Yilmaz (Leitung Wareneingang): Umfang, Befugnisse und Budget sind klar abgegrenzt, die Annahme ist dokumentiert. Die Restpflicht der Geschäftsführung zur Überwachung ist als Maßnahme mit Frequenz erfasst – die letzte Kontrolle ist älter als ein Jahr, deshalb Handlungsbedarf.</a:t>
+              <a:t>Der Ausfuhrverantwortliche (Mitglied der Geschäftsführung) bleibt gegenüber dem BAFA persönlich verantwortlich. Mit der Beauftragung überträgt er die operative Exportkontrolle an Karsten Eschamann: klar abgegrenzter Umfang, Befugnisse bis zum Lieferstopp, Budget der Kostenstelle 4710. Die Beauftragung ist schriftlich, angenommen und wird quartalsweise überwacht.</a:t>
             </a:r>
             <a:endParaRPr lang="en-US" dirty="0"/>
           </a:p>
@@ -2329,7 +2329,7 @@
                   <a:srgbClr val="C2255C"/>
                 </a:solidFill>
               </a:rPr>
-              <a:t>Bezug: Rolle (z. B. Bestellung ISB)</a:t>
+              <a:t>Bezug: Rolle (z. B. Trade Compliance)</a:t>
             </a:r>
             <a:endParaRPr lang="en-US" sz="1100" dirty="0"/>
           </a:p>
@@ -2376,7 +2376,7 @@
                   <a:srgbClr val="5F6B7A"/>
                 </a:solidFill>
               </a:rPr>
-              <a:t>Dr. Anna Berger → Stelle „Leiterin Einkauf“ → Rollen „Leitung Einkauf“, „Kostenstellenverantwortlicher“ → Gesamtprokura DV-007 (wirksam)</a:t>
+              <a:t>Karsten Eschamann → Stelle „Director Export Control &amp; Customs“ → Rollen „Trade Compliance Beauftragter“, „Kostenstellenverantwortlicher“ → Beauftragung DV-014 durch Konrad Garhammer (GF / Ausfuhrverantwortlicher)</a:t>
             </a:r>
             <a:endParaRPr lang="en-US" sz="1200" dirty="0"/>
           </a:p>
@@ -2484,7 +2484,7 @@
                   <a:schemeClr val="tx2"/>
                 </a:solidFill>
               </a:rPr>
-              <a:t>Maske Stelle: Leiterin / Leiter Einkauf (ST-002)</a:t>
+              <a:t>Maske Stelle: Director Export Control &amp; Customs (ST-014)</a:t>
             </a:r>
             <a:endParaRPr lang="en-US" sz="3000" dirty="0"/>
           </a:p>
@@ -2522,7 +2522,7 @@
                   <a:srgbClr val="AE3EC9"/>
                 </a:solidFill>
               </a:rPr>
-              <a:t>Befugnisse der Stelle</a:t>
+              <a:t>Karsten Eschamann</a:t>
             </a:r>
             <a:pPr algn="l" indent="0" marL="0">
               <a:buNone/>
@@ -2533,7 +2533,7 @@
                   <a:srgbClr val="5F6B7A"/>
                 </a:solidFill>
               </a:rPr>
-              <a:t> sind das Soll (Weisung, Budget, Prokura, Limit 250.000 EUR) – die Gesamtprokura von Dr. Anna Berger ist das Ist.</a:t>
+              <a:t> – disziplinarisch an Andreas Obermaier (Head of Legal &amp; Compliance), fachlich an den Ausfuhrverantwortlichen.</a:t>
             </a:r>
             <a:endParaRPr lang="en-US" sz="1400" dirty="0"/>
           </a:p>
@@ -2573,7 +2573,7 @@
       </p:sp>
       <p:pic>
         <p:nvPicPr>
-          <p:cNvPr id="5" name="Image 0" descr="Maske Maske Stelle: Leiterin / Leiter Einkauf (ST-002), Ausschnitt 1">    </p:cNvPr>
+          <p:cNvPr id="5" name="Image 0" descr="Maske Maske Stelle: Director Export Control &amp; Customs (ST-014), Ausschnitt 1">    </p:cNvPr>
           <p:cNvPicPr>
             <a:picLocks noChangeAspect="1"/>
           </p:cNvPicPr>
@@ -2629,7 +2629,7 @@
       </p:sp>
       <p:pic>
         <p:nvPicPr>
-          <p:cNvPr id="7" name="Image 1" descr="Maske Maske Stelle: Leiterin / Leiter Einkauf (ST-002), Ausschnitt 2">    </p:cNvPr>
+          <p:cNvPr id="7" name="Image 1" descr="Maske Maske Stelle: Director Export Control &amp; Customs (ST-014), Ausschnitt 2">    </p:cNvPr>
           <p:cNvPicPr>
             <a:picLocks noChangeAspect="1"/>
           </p:cNvPicPr>
@@ -2660,7 +2660,7 @@
         <p:spPr>
           <a:xfrm>
             <a:off x="4297680" y="4214319"/>
-            <a:ext cx="3602736" cy="1902569"/>
+            <a:ext cx="3602736" cy="1775342"/>
           </a:xfrm>
           <a:prstGeom prst="rect">
             <a:avLst/>
@@ -2685,7 +2685,7 @@
       </p:sp>
       <p:pic>
         <p:nvPicPr>
-          <p:cNvPr id="9" name="Image 2" descr="Maske Maske Stelle: Leiterin / Leiter Einkauf (ST-002), Ausschnitt 2">    </p:cNvPr>
+          <p:cNvPr id="9" name="Image 2" descr="Maske Maske Stelle: Director Export Control &amp; Customs (ST-014), Ausschnitt 2">    </p:cNvPr>
           <p:cNvPicPr>
             <a:picLocks noChangeAspect="1"/>
           </p:cNvPicPr>
@@ -2700,7 +2700,7 @@
         <p:spPr>
           <a:xfrm>
             <a:off x="4315968" y="4232607"/>
-            <a:ext cx="3566160" cy="1865993"/>
+            <a:ext cx="3566160" cy="1738766"/>
           </a:xfrm>
           <a:prstGeom prst="rect">
             <a:avLst/>
@@ -2741,7 +2741,7 @@
       </p:sp>
       <p:pic>
         <p:nvPicPr>
-          <p:cNvPr id="11" name="Image 3" descr="Maske Maske Stelle: Leiterin / Leiter Einkauf (ST-002), Ausschnitt 3">    </p:cNvPr>
+          <p:cNvPr id="11" name="Image 3" descr="Maske Maske Stelle: Director Export Control &amp; Customs (ST-014), Ausschnitt 3">    </p:cNvPr>
           <p:cNvPicPr>
             <a:picLocks noChangeAspect="1"/>
           </p:cNvPicPr>
@@ -2797,7 +2797,7 @@
       </p:sp>
       <p:pic>
         <p:nvPicPr>
-          <p:cNvPr id="13" name="Image 4" descr="Maske Maske Stelle: Leiterin / Leiter Einkauf (ST-002), Ausschnitt 3">    </p:cNvPr>
+          <p:cNvPr id="13" name="Image 4" descr="Maske Maske Stelle: Director Export Control &amp; Customs (ST-014), Ausschnitt 3">    </p:cNvPr>
           <p:cNvPicPr>
             <a:picLocks noChangeAspect="1"/>
           </p:cNvPicPr>
@@ -2921,7 +2921,7 @@
                   <a:schemeClr val="tx2"/>
                 </a:solidFill>
               </a:rPr>
-              <a:t>Maske Rolle: Informationssicherheitsbeauftragter (RO-007)</a:t>
+              <a:t>Maske Rolle: Kostenstellenverantwortlicher (RO-002)</a:t>
             </a:r>
             <a:endParaRPr lang="en-US" sz="3000" dirty="0"/>
           </a:p>
@@ -2959,7 +2959,7 @@
                   <a:srgbClr val="7048E8"/>
                 </a:solidFill>
               </a:rPr>
-              <a:t>Erforderliche Übertragung</a:t>
+              <a:t>Role Owner Torsten Blaschke</a:t>
             </a:r>
             <a:pPr algn="l" indent="0" marL="0">
               <a:buNone/>
@@ -2970,7 +2970,7 @@
                   <a:srgbClr val="5F6B7A"/>
                 </a:solidFill>
               </a:rPr>
-              <a:t>: Jonas Neumann ist wirksam bestellt, für den Stellvertreter Daniel Becker fehlt die Bestellung.</a:t>
+              <a:t> (Controlling) pflegt die Rolle – ausgeübt wird sie über die Stellen, u. a. von Karsten Eschamann.</a:t>
             </a:r>
             <a:endParaRPr lang="en-US" sz="1400" dirty="0"/>
           </a:p>
@@ -2985,7 +2985,7 @@
         <p:spPr>
           <a:xfrm>
             <a:off x="457200" y="1353312"/>
-            <a:ext cx="3602736" cy="5099142"/>
+            <a:ext cx="3602736" cy="4627342"/>
           </a:xfrm>
           <a:prstGeom prst="rect">
             <a:avLst/>
@@ -3010,7 +3010,7 @@
       </p:sp>
       <p:pic>
         <p:nvPicPr>
-          <p:cNvPr id="5" name="Image 0" descr="Maske Maske Rolle: Informationssicherheitsbeauftragter (RO-007), Ausschnitt 1">    </p:cNvPr>
+          <p:cNvPr id="5" name="Image 0" descr="Maske Maske Rolle: Kostenstellenverantwortlicher (RO-002), Ausschnitt 1">    </p:cNvPr>
           <p:cNvPicPr>
             <a:picLocks noChangeAspect="1"/>
           </p:cNvPicPr>
@@ -3025,7 +3025,7 @@
         <p:spPr>
           <a:xfrm>
             <a:off x="475488" y="1371600"/>
-            <a:ext cx="3566160" cy="5062566"/>
+            <a:ext cx="3566160" cy="4590766"/>
           </a:xfrm>
           <a:prstGeom prst="rect">
             <a:avLst/>
@@ -3041,7 +3041,7 @@
         <p:spPr>
           <a:xfrm>
             <a:off x="4297680" y="1353312"/>
-            <a:ext cx="3602736" cy="4728063"/>
+            <a:ext cx="3602736" cy="4372889"/>
           </a:xfrm>
           <a:prstGeom prst="rect">
             <a:avLst/>
@@ -3066,7 +3066,7 @@
       </p:sp>
       <p:pic>
         <p:nvPicPr>
-          <p:cNvPr id="7" name="Image 1" descr="Maske Maske Rolle: Informationssicherheitsbeauftragter (RO-007), Ausschnitt 2">    </p:cNvPr>
+          <p:cNvPr id="7" name="Image 1" descr="Maske Maske Rolle: Kostenstellenverantwortlicher (RO-002), Ausschnitt 2">    </p:cNvPr>
           <p:cNvPicPr>
             <a:picLocks noChangeAspect="1"/>
           </p:cNvPicPr>
@@ -3081,7 +3081,7 @@
         <p:spPr>
           <a:xfrm>
             <a:off x="4315968" y="1371600"/>
-            <a:ext cx="3566160" cy="4691487"/>
+            <a:ext cx="3566160" cy="4336313"/>
           </a:xfrm>
           <a:prstGeom prst="rect">
             <a:avLst/>
@@ -3097,7 +3097,7 @@
         <p:spPr>
           <a:xfrm>
             <a:off x="8138160" y="1353312"/>
-            <a:ext cx="3602736" cy="2475089"/>
+            <a:ext cx="3602736" cy="2157022"/>
           </a:xfrm>
           <a:prstGeom prst="rect">
             <a:avLst/>
@@ -3122,7 +3122,7 @@
       </p:sp>
       <p:pic>
         <p:nvPicPr>
-          <p:cNvPr id="9" name="Image 2" descr="Maske Maske Rolle: Informationssicherheitsbeauftragter (RO-007), Ausschnitt 3">    </p:cNvPr>
+          <p:cNvPr id="9" name="Image 2" descr="Maske Maske Rolle: Kostenstellenverantwortlicher (RO-002), Ausschnitt 3">    </p:cNvPr>
           <p:cNvPicPr>
             <a:picLocks noChangeAspect="1"/>
           </p:cNvPicPr>
@@ -3137,7 +3137,7 @@
         <p:spPr>
           <a:xfrm>
             <a:off x="8156448" y="1371600"/>
-            <a:ext cx="3566160" cy="2438513"/>
+            <a:ext cx="3566160" cy="2120446"/>
           </a:xfrm>
           <a:prstGeom prst="rect">
             <a:avLst/>
@@ -3246,7 +3246,7 @@
                   <a:schemeClr val="tx2"/>
                 </a:solidFill>
               </a:rPr>
-              <a:t>Maske Übertragung: Pflichtendelegation Arbeitsschutz (DV-011)</a:t>
+              <a:t>Maske Übertragung: Trade Compliance Beauftragter (DV-014)</a:t>
             </a:r>
             <a:endParaRPr lang="en-US" sz="3000" dirty="0"/>
           </a:p>
@@ -3295,7 +3295,7 @@
                   <a:srgbClr val="5F6B7A"/>
                 </a:solidFill>
               </a:rPr>
-              <a:t> – schriftlich übertragen und angenommen. Aber: die Überwachung durch den Delegierenden ist seit Juni überfällig.</a:t>
+              <a:t> – beauftragt durch Konrad Garhammer (GF / Ausfuhrverantwortlicher), angenommen von Karsten Eschamann.</a:t>
             </a:r>
             <a:endParaRPr lang="en-US" sz="1400" dirty="0"/>
           </a:p>
@@ -3310,7 +3310,7 @@
         <p:spPr>
           <a:xfrm>
             <a:off x="457200" y="1353312"/>
-            <a:ext cx="3602736" cy="4107833"/>
+            <a:ext cx="3602736" cy="3747357"/>
           </a:xfrm>
           <a:prstGeom prst="rect">
             <a:avLst/>
@@ -3335,7 +3335,7 @@
       </p:sp>
       <p:pic>
         <p:nvPicPr>
-          <p:cNvPr id="5" name="Image 0" descr="Maske Maske Übertragung: Pflichtendelegation Arbeitsschutz (DV-011), Ausschnitt 1">    </p:cNvPr>
+          <p:cNvPr id="5" name="Image 0" descr="Maske Maske Übertragung: Trade Compliance Beauftragter (DV-014), Ausschnitt 1">    </p:cNvPr>
           <p:cNvPicPr>
             <a:picLocks noChangeAspect="1"/>
           </p:cNvPicPr>
@@ -3350,7 +3350,7 @@
         <p:spPr>
           <a:xfrm>
             <a:off x="475488" y="1371600"/>
-            <a:ext cx="3566160" cy="4071257"/>
+            <a:ext cx="3566160" cy="3710781"/>
           </a:xfrm>
           <a:prstGeom prst="rect">
             <a:avLst/>
@@ -3391,7 +3391,7 @@
       </p:sp>
       <p:pic>
         <p:nvPicPr>
-          <p:cNvPr id="7" name="Image 1" descr="Maske Maske Übertragung: Pflichtendelegation Arbeitsschutz (DV-011), Ausschnitt 2">    </p:cNvPr>
+          <p:cNvPr id="7" name="Image 1" descr="Maske Maske Übertragung: Trade Compliance Beauftragter (DV-014), Ausschnitt 2">    </p:cNvPr>
           <p:cNvPicPr>
             <a:picLocks noChangeAspect="1"/>
           </p:cNvPicPr>
@@ -3447,7 +3447,7 @@
       </p:sp>
       <p:pic>
         <p:nvPicPr>
-          <p:cNvPr id="9" name="Image 2" descr="Maske Maske Übertragung: Pflichtendelegation Arbeitsschutz (DV-011), Ausschnitt 3">    </p:cNvPr>
+          <p:cNvPr id="9" name="Image 2" descr="Maske Maske Übertragung: Trade Compliance Beauftragter (DV-014), Ausschnitt 3">    </p:cNvPr>
           <p:cNvPicPr>
             <a:picLocks noChangeAspect="1"/>
           </p:cNvPicPr>
@@ -3547,7 +3547,7 @@
                   <a:srgbClr val="1F2933"/>
                 </a:solidFill>
               </a:rPr>
-              <a:t>Klar abgegrenzter Umfang mit Befugnissen und Budget</a:t>
+              <a:t>Ausfuhrverantwortlicher bleibt persönlich verantwortlich</a:t>
             </a:r>
             <a:endParaRPr lang="en-US" sz="1600" dirty="0"/>
           </a:p>
@@ -3565,7 +3565,7 @@
                   <a:srgbClr val="1F2933"/>
                 </a:solidFill>
               </a:rPr>
-              <a:t>Wirksam erst mit dokumentierter Annahme</a:t>
+              <a:t>Klarer Umfang mit Lieferstopp-Befugnis und Budget</a:t>
             </a:r>
             <a:endParaRPr lang="en-US" sz="1600" dirty="0"/>
           </a:p>
@@ -3583,7 +3583,7 @@
                   <a:srgbClr val="1F2933"/>
                 </a:solidFill>
               </a:rPr>
-              <a:t>Überwachung bleibt beim Delegierenden (§ 130 OWiG)</a:t>
+              <a:t>Wirksam erst mit Annahme; Überwachung quartalsweise</a:t>
             </a:r>
             <a:endParaRPr lang="en-US" sz="1600" dirty="0"/>
           </a:p>

</xml_diff>